<commit_message>
Corrige cardinalidades ausentes/sobrepostas no DER
- Relacao PRODUTO-TD (especializacao) nao tinha cardinalidade do lado
  de PRODUTO; adicionado "1,1", igual aos demais relacionamentos de
  PRODUTO.
- Em entidades-hub com 3-4 relacionamentos (PEDIDO, PRODUTO,
  EXECUCAO_ETAPA), varios rotulos de cardinalidade colidiam entre si
  e com atributos vizinhos, tornando-os ilegiveis ou aparentemente
  ausentes. card_label() agora distancia cada rotulo do centro da
  entidade por um valor absoluto que respeita o tamanho da propria
  caixa (antes a caixa, desenhada por cima, podia cobrir parte do
  texto), e espalha rotulos sucessivos da mesma entidade em passos
  crescentes ao longo da linha, alternando de lado.
- Diagrama regenerado e reexportado para Diagrama/Diagrama.png;
  apresentacao.pptx reconstruido para embutir a imagem corrigida.

Co-Authored-By: Claude Sonnet 5 <noreply@anthropic.com>
</commit_message>
<xml_diff>
--- a/Entrega2/apresentacao.pptx
+++ b/Entrega2/apresentacao.pptx
@@ -118,19 +118,19 @@
   <p:extLst>
     <p:ext uri="{521415D9-36F7-43E2-AB2F-B90AF26B5E84}">
       <p14:sectionLst xmlns:p14="http://schemas.microsoft.com/office/powerpoint/2010/main">
-        <p14:section name="Abertura" id="{88cae2e6-2166-9c9e-7d4f-28de166f1e66}">
+        <p14:section name="Abertura" id="{a737b780-7757-47bc-0e76-b255e703d270}">
           <p14:sldIdLst>
             <p14:sldId id="256"/>
           </p14:sldIdLst>
         </p14:section>
-        <p14:section name="Problema e Solucao" id="{8a6accb7-f4b9-b62b-923f-9410bdbd6379}">
+        <p14:section name="Problema e Solucao" id="{a3b882bf-e73c-48b8-97c6-c3bb44b9a042}">
           <p14:sldIdLst>
             <p14:sldId id="257"/>
             <p14:sldId id="258"/>
             <p14:sldId id="259"/>
           </p14:sldIdLst>
         </p14:section>
-        <p14:section name="Modelo e Implementacao" id="{58989bc0-4d0e-1a30-a046-27bd0315cd78}">
+        <p14:section name="Modelo e Implementacao" id="{ab5ac4e4-20f8-6a9d-9987-a5c4742be35d}">
           <p14:sldIdLst>
             <p14:sldId id="260"/>
             <p14:sldId id="261"/>
@@ -138,7 +138,7 @@
             <p14:sldId id="263"/>
           </p14:sldIdLst>
         </p14:section>
-        <p14:section name="Valor e Proximos Passos" id="{8425a323-62d3-e977-dac4-58ab7c8cd848}">
+        <p14:section name="Valor e Proximos Passos" id="{e67eb191-febc-616f-aa5a-9f760fb030f6}">
           <p14:sldIdLst>
             <p14:sldId id="264"/>
             <p14:sldId id="265"/>

</xml_diff>

<commit_message>
Renomeia artesao_faccao para artesao na apresentacao
Co-Authored-By: Claude Sonnet 5 <noreply@anthropic.com>
</commit_message>
<xml_diff>
--- a/Entrega2/apresentacao.pptx
+++ b/Entrega2/apresentacao.pptx
@@ -1742,7 +1742,7 @@
           <a:p>
             <a:r>
               <a:rPr lang="en-US" dirty="0"/>
-              <a:t>As 8 tabelas que respondem diretamente a avaliacao do professor: ordem de producao com suas etapas e artesaos/faccoes (producao), e contas a receber/pagar (financeiro) - nenhuma existia na versao anterior.</a:t>
+              <a:t>As 8 tabelas que respondem diretamente a avaliacao do professor: ordem de producao com suas etapas e artesaos (producao), e contas a receber/pagar (financeiro) - nenhuma existia na versao anterior.</a:t>
             </a:r>
             <a:endParaRPr lang="en-US" dirty="0"/>
           </a:p>
@@ -4368,7 +4368,7 @@
                 <a:ea typeface="Calibri" pitchFamily="34" charset="-122"/>
                 <a:cs typeface="Calibri" pitchFamily="34" charset="-120"/>
               </a:rPr>
-              <a:t>Cadê ordem de produção, financeiro? — Foi exatamente o que o professor apontou (issue #1): adicionamos ORDEM_PRODUÇÃO, ETAPA_PRODUÇÃO, ARTESÃO_FACÇÃO, EXECUÇÃO_ETAPA, VENDEDOR, CONTAS_RECEBER e CONTAS_PAGAR.</a:t>
+              <a:t>Cadê ordem de produção, financeiro? — Foi exatamente o que o professor apontou (issue #1): adicionamos ORDEM_PRODUÇÃO, ETAPA_PRODUÇÃO, ARTESÃO, EXECUÇÃO_ETAPA, VENDEDOR, CONTAS_RECEBER e CONTAS_PAGAR.</a:t>
             </a:r>
             <a:endParaRPr lang="en-US" sz="1500" dirty="0"/>
           </a:p>
@@ -5908,7 +5908,7 @@
                           <a:ea typeface="Calibri" pitchFamily="34" charset="-122"/>
                           <a:cs typeface="Calibri" pitchFamily="34" charset="-120"/>
                         </a:rPr>
-                        <a:t>Entidade adicionada, com ETAPA_PRODUÇÃO, ARTESÃO_FACÇÃO e EXECUÇÃO_ETAPA</a:t>
+                        <a:t>Entidade adicionada, com ETAPA_PRODUÇÃO, ARTESÃO e EXECUÇÃO_ETAPA</a:t>
                       </a:r>
                       <a:endParaRPr lang="en-US" sz="1250" dirty="0">
                         <a:latin typeface="Calibri" charset="0"/>
@@ -9295,7 +9295,7 @@
                           <a:ea typeface="Calibri" pitchFamily="34" charset="-122"/>
                           <a:cs typeface="Calibri" pitchFamily="34" charset="-120"/>
                         </a:rPr>
-                        <a:t>artesao_faccao</a:t>
+                        <a:t>artesao</a:t>
                       </a:r>
                       <a:endParaRPr lang="en-US" sz="1150" dirty="0">
                         <a:latin typeface="Calibri" charset="0"/>
@@ -9637,7 +9637,7 @@
                           <a:ea typeface="Calibri" pitchFamily="34" charset="-122"/>
                           <a:cs typeface="Calibri" pitchFamily="34" charset="-120"/>
                         </a:rPr>
-                        <a:t>op_id → ordem_producao; etapa_id → etapa_producao; artesao_id → artesao_faccao</a:t>
+                        <a:t>op_id → ordem_producao; etapa_id → etapa_producao; artesao_id → artesao</a:t>
                       </a:r>
                       <a:endParaRPr lang="en-US" sz="1150" dirty="0">
                         <a:latin typeface="Calibri" charset="0"/>
@@ -11662,7 +11662,7 @@
                 <a:ea typeface="Calibri" pitchFamily="34" charset="-122"/>
                 <a:cs typeface="Calibri" pitchFamily="34" charset="-120"/>
               </a:rPr>
-              <a:t>8.6 Aproveitamento de corte por artesão/facção (RF15)</a:t>
+              <a:t>8.6 Aproveitamento de corte por artesão (RF15)</a:t>
             </a:r>
             <a:endParaRPr lang="en-US" sz="1350" dirty="0"/>
           </a:p>

</xml_diff>